<commit_message>
Checkpoint teaching decks, assessments and holiday camp materials
</commit_message>
<xml_diff>
--- a/DataAnalysis_Track/decks/DA_S01_From_a_spreadsheet_to_data.pptx
+++ b/DataAnalysis_Track/decks/DA_S01_From_a_spreadsheet_to_data.pptx
@@ -480,7 +480,7 @@
 </file>
 
 <file path=ppt/notesSlides/notesSlide1.xml><?xml version="1.0" encoding="utf-8"?>
-<p:notes xmlns:a="http://schemas.openxmlformats.org/drawingml/2006/main" xmlns:p="http://schemas.openxmlformats.org/presentationml/2006/main" xmlns:r="http://schemas.openxmlformats.org/officeDocument/2006/relationships">
+<p:notes xmlns:a="http://schemas.openxmlformats.org/drawingml/2006/main" xmlns:p="http://schemas.openxmlformats.org/presentationml/2006/main">
   <p:cSld>
     <p:spTree>
       <p:nvGrpSpPr>
@@ -524,7 +524,87 @@
           <a:lstStyle/>
           <a:p>
             <a:r>
+              <a:t>TEACHING PURPOSE</a:t>
+            </a:r>
+          </a:p>
+          <a:p>
+            <a:r>
+              <a:t>From a spreadsheet to data</a:t>
+            </a:r>
+          </a:p>
+          <a:p>
+            <a:r>
+              <a:t/>
+            </a:r>
+          </a:p>
+          <a:p>
+            <a:r>
+              <a:t>LECTURER CUE</a:t>
+            </a:r>
+          </a:p>
+          <a:p>
+            <a:r>
               <a:t>Start on time.</a:t>
+            </a:r>
+          </a:p>
+          <a:p>
+            <a:r>
+              <a:t/>
+            </a:r>
+          </a:p>
+          <a:p>
+            <a:r>
+              <a:t>EXPLAIN IN ORDINARY WORDS</a:t>
+            </a:r>
+          </a:p>
+          <a:p>
+            <a:r>
+              <a:t>An observation describes the data. A finding answers a defined question with evidence. A recommendation adds an action, its justification and limits.</a:t>
+            </a:r>
+          </a:p>
+          <a:p>
+            <a:r>
+              <a:t/>
+            </a:r>
+          </a:p>
+          <a:p>
+            <a:r>
+              <a:t>CHECK AND EXPECTED ANSWER</a:t>
+            </a:r>
+          </a:p>
+          <a:p>
+            <a:r>
+              <a:t>Does a difference between two groups prove one caused the other? No. Other differences or selection may explain it.</a:t>
+            </a:r>
+          </a:p>
+          <a:p>
+            <a:r>
+              <a:t/>
+            </a:r>
+          </a:p>
+          <a:p>
+            <a:r>
+              <a:t>IF LEARNERS ARE STUCK</a:t>
+            </a:r>
+          </a:p>
+          <a:p>
+            <a:r>
+              <a:t>Ask for the population, time period, number and comparison. Then ask what additional evidence could change the recommendation.</a:t>
+            </a:r>
+          </a:p>
+          <a:p>
+            <a:r>
+              <a:t/>
+            </a:r>
+          </a:p>
+          <a:p>
+            <a:r>
+              <a:t>NEXT</a:t>
+            </a:r>
+          </a:p>
+          <a:p>
+            <a:r>
+              <a:t>Where tonight sits. Move on after a learner can explain the current example or required action.</a:t>
             </a:r>
           </a:p>
         </p:txBody>
@@ -550,7 +630,7 @@
 </file>
 
 <file path=ppt/notesSlides/notesSlide10.xml><?xml version="1.0" encoding="utf-8"?>
-<p:notes xmlns:a="http://schemas.openxmlformats.org/drawingml/2006/main" xmlns:p="http://schemas.openxmlformats.org/presentationml/2006/main" xmlns:r="http://schemas.openxmlformats.org/officeDocument/2006/relationships">
+<p:notes xmlns:a="http://schemas.openxmlformats.org/drawingml/2006/main" xmlns:p="http://schemas.openxmlformats.org/presentationml/2006/main">
   <p:cSld>
     <p:spTree>
       <p:nvGrpSpPr>
@@ -594,7 +674,102 @@
           <a:lstStyle/>
           <a:p>
             <a:r>
-              <a:t>What kind of value a column holds: whole number, decimal, text, date, or true/false. A column has ONE type, all the way down.</a:t>
+              <a:t>TEACHING PURPOSE</a:t>
+            </a:r>
+          </a:p>
+          <a:p>
+            <a:r>
+              <a:t>Data type</a:t>
+            </a:r>
+          </a:p>
+          <a:p>
+            <a:r>
+              <a:t/>
+            </a:r>
+          </a:p>
+          <a:p>
+            <a:r>
+              <a:t>CONNECT</a:t>
+            </a:r>
+          </a:p>
+          <a:p>
+            <a:r>
+              <a:t>Build on the preceding slide: Grain.</a:t>
+            </a:r>
+          </a:p>
+          <a:p>
+            <a:r>
+              <a:t/>
+            </a:r>
+          </a:p>
+          <a:p>
+            <a:r>
+              <a:t>LECTURER CUE</a:t>
+            </a:r>
+          </a:p>
+          <a:p>
+            <a:r>
+              <a:t>A column’s intended type: integer, decimal, text, date or Boolean. Check imported values.</a:t>
+            </a:r>
+          </a:p>
+          <a:p>
+            <a:r>
+              <a:t/>
+            </a:r>
+          </a:p>
+          <a:p>
+            <a:r>
+              <a:t>EXPLAIN IN ORDINARY WORDS</a:t>
+            </a:r>
+          </a:p>
+          <a:p>
+            <a:r>
+              <a:t>A notebook contains code cells and explanatory text cells. The runtime remembers values from cells that actually ran, which may differ from their visual order.</a:t>
+            </a:r>
+          </a:p>
+          <a:p>
+            <a:r>
+              <a:t/>
+            </a:r>
+          </a:p>
+          <a:p>
+            <a:r>
+              <a:t>CHECK AND EXPECTED ANSWER</a:t>
+            </a:r>
+          </a:p>
+          <a:p>
+            <a:r>
+              <a:t>Does editing a cell update a value already stored in memory? No; the cell must run.</a:t>
+            </a:r>
+          </a:p>
+          <a:p>
+            <a:r>
+              <a:t/>
+            </a:r>
+          </a:p>
+          <a:p>
+            <a:r>
+              <a:t>IF LEARNERS ARE STUCK</a:t>
+            </a:r>
+          </a:p>
+          <a:p>
+            <a:r>
+              <a:t>Outside an assessment restriction, restart and run from the top after loading data. Fix the first error before later cells; save the successful notebook.</a:t>
+            </a:r>
+          </a:p>
+          <a:p>
+            <a:r>
+              <a:t/>
+            </a:r>
+          </a:p>
+          <a:p>
+            <a:r>
+              <a:t>NEXT</a:t>
+            </a:r>
+          </a:p>
+          <a:p>
+            <a:r>
+              <a:t>Break. Move on after a learner can explain the current example or required action.</a:t>
             </a:r>
           </a:p>
         </p:txBody>
@@ -619,8 +794,8 @@
 </p:notes>
 </file>
 
-<file path=ppt/notesSlides/notesSlide11.xml><?xml version="1.0" encoding="utf-8"?>
-<p:notes xmlns:a="http://schemas.openxmlformats.org/drawingml/2006/main" xmlns:p="http://schemas.openxmlformats.org/presentationml/2006/main" xmlns:r="http://schemas.openxmlformats.org/officeDocument/2006/relationships">
+<file path=ppt/notesSlides/notesSlide10006.xml><?xml version="1.0" encoding="utf-8"?>
+<p:notes xmlns:a="http://schemas.openxmlformats.org/drawingml/2006/main" xmlns:p="http://schemas.openxmlformats.org/presentationml/2006/main">
   <p:cSld>
     <p:spTree>
       <p:nvGrpSpPr>
@@ -664,7 +839,87 @@
           <a:lstStyle/>
           <a:p>
             <a:r>
-              <a:t>Ten minutes.</a:t>
+              <a:t>TEACHING PURPOSE</a:t>
+            </a:r>
+          </a:p>
+          <a:p>
+            <a:r>
+              <a:t>What you were asked, and what you can answer</a:t>
+            </a:r>
+          </a:p>
+          <a:p>
+            <a:r>
+              <a:t/>
+            </a:r>
+          </a:p>
+          <a:p>
+            <a:r>
+              <a:t>CONNECT</a:t>
+            </a:r>
+          </a:p>
+          <a:p>
+            <a:r>
+              <a:t>Build on the preceding slide: What is the difference between what you were asked.</a:t>
+            </a:r>
+          </a:p>
+          <a:p>
+            <a:r>
+              <a:t/>
+            </a:r>
+          </a:p>
+          <a:p>
+            <a:r>
+              <a:t>EXPLAIN IN ORDINARY WORDS</a:t>
+            </a:r>
+          </a:p>
+          <a:p>
+            <a:r>
+              <a:t>An observation describes the data. A finding answers a defined question with evidence. A recommendation adds an action, its justification and limits.</a:t>
+            </a:r>
+          </a:p>
+          <a:p>
+            <a:r>
+              <a:t/>
+            </a:r>
+          </a:p>
+          <a:p>
+            <a:r>
+              <a:t>CHECK AND EXPECTED ANSWER</a:t>
+            </a:r>
+          </a:p>
+          <a:p>
+            <a:r>
+              <a:t>Does a difference between two groups prove one caused the other? No. Other differences or selection may explain it.</a:t>
+            </a:r>
+          </a:p>
+          <a:p>
+            <a:r>
+              <a:t/>
+            </a:r>
+          </a:p>
+          <a:p>
+            <a:r>
+              <a:t>IF LEARNERS ARE STUCK</a:t>
+            </a:r>
+          </a:p>
+          <a:p>
+            <a:r>
+              <a:t>Ask for the population, time period, number and comparison. Then ask what additional evidence could change the recommendation.</a:t>
+            </a:r>
+          </a:p>
+          <a:p>
+            <a:r>
+              <a:t/>
+            </a:r>
+          </a:p>
+          <a:p>
+            <a:r>
+              <a:t>NEXT</a:t>
+            </a:r>
+          </a:p>
+          <a:p>
+            <a:r>
+              <a:t>Four requests, as they actually arrive. Move on after a learner can explain the current example or required action.</a:t>
             </a:r>
           </a:p>
         </p:txBody>
@@ -689,8 +944,8 @@
 </p:notes>
 </file>
 
-<file path=ppt/notesSlides/notesSlide12.xml><?xml version="1.0" encoding="utf-8"?>
-<p:notes xmlns:a="http://schemas.openxmlformats.org/drawingml/2006/main" xmlns:p="http://schemas.openxmlformats.org/presentationml/2006/main" xmlns:r="http://schemas.openxmlformats.org/officeDocument/2006/relationships">
+<file path=ppt/notesSlides/notesSlide10013.xml><?xml version="1.0" encoding="utf-8"?>
+<p:notes xmlns:a="http://schemas.openxmlformats.org/drawingml/2006/main" xmlns:p="http://schemas.openxmlformats.org/presentationml/2006/main">
   <p:cSld>
     <p:spTree>
       <p:nvGrpSpPr>
@@ -734,7 +989,57 @@
           <a:lstStyle/>
           <a:p>
             <a:r>
-              <a:t>The first five real rows of orders.csv. Everything you already know about a spreadsheet still applies; the words change and one new idea, the primary key, arrives.</a:t>
+              <a:t>TEACHING PURPOSE</a:t>
+            </a:r>
+          </a:p>
+          <a:p>
+            <a:r>
+              <a:t>The words, on a real table</a:t>
+            </a:r>
+          </a:p>
+          <a:p>
+            <a:r>
+              <a:t/>
+            </a:r>
+          </a:p>
+          <a:p>
+            <a:r>
+              <a:t>CONNECT</a:t>
+            </a:r>
+          </a:p>
+          <a:p>
+            <a:r>
+              <a:t>Build on the preceding slide: Break.</a:t>
+            </a:r>
+          </a:p>
+          <a:p>
+            <a:r>
+              <a:t/>
+            </a:r>
+          </a:p>
+          <a:p>
+            <a:r>
+              <a:t>DELIVER THIS SLIDE</a:t>
+            </a:r>
+          </a:p>
+          <a:p>
+            <a:r>
+              <a:t>Read the stated purpose, then point to the named example or action on the slide. Ask learners to describe what they will do before moving on. For a break slide, announce the return time; for a section divider, name the next concrete task.</a:t>
+            </a:r>
+          </a:p>
+          <a:p>
+            <a:r>
+              <a:t/>
+            </a:r>
+          </a:p>
+          <a:p>
+            <a:r>
+              <a:t>NEXT</a:t>
+            </a:r>
+          </a:p>
+          <a:p>
+            <a:r>
+              <a:t>One table. Five words you will hear all term.. Move on after a learner can explain the current example or required action.</a:t>
             </a:r>
           </a:p>
         </p:txBody>
@@ -759,8 +1064,8 @@
 </p:notes>
 </file>
 
-<file path=ppt/notesSlides/notesSlide13.xml><?xml version="1.0" encoding="utf-8"?>
-<p:notes xmlns:a="http://schemas.openxmlformats.org/drawingml/2006/main" xmlns:p="http://schemas.openxmlformats.org/presentationml/2006/main" xmlns:r="http://schemas.openxmlformats.org/officeDocument/2006/relationships">
+<file path=ppt/notesSlides/notesSlide11.xml><?xml version="1.0" encoding="utf-8"?>
+<p:notes xmlns:a="http://schemas.openxmlformats.org/drawingml/2006/main" xmlns:p="http://schemas.openxmlformats.org/presentationml/2006/main">
   <p:cSld>
     <p:spTree>
       <p:nvGrpSpPr>
@@ -802,7 +1107,61 @@
         <p:txBody>
           <a:bodyPr/>
           <a:lstStyle/>
-          <a:p/>
+          <a:p>
+            <a:r>
+              <a:t>TEACHING PURPOSE</a:t>
+            </a:r>
+          </a:p>
+          <a:p>
+            <a:r>
+              <a:t>Break</a:t>
+            </a:r>
+          </a:p>
+          <a:p>
+            <a:r>
+              <a:t/>
+            </a:r>
+          </a:p>
+          <a:p>
+            <a:r>
+              <a:t>CONNECT</a:t>
+            </a:r>
+          </a:p>
+          <a:p>
+            <a:r>
+              <a:t>Build on the preceding slide: Data type.</a:t>
+            </a:r>
+          </a:p>
+          <a:p>
+            <a:r>
+              <a:t/>
+            </a:r>
+          </a:p>
+          <a:p>
+            <a:r>
+              <a:t>LECTURER CUE</a:t>
+            </a:r>
+          </a:p>
+          <a:p>
+            <a:r>
+              <a:t>Ten minutes.</a:t>
+            </a:r>
+          </a:p>
+          <a:p>
+            <a:r>
+              <a:t/>
+            </a:r>
+          </a:p>
+          <a:p>
+            <a:r>
+              <a:t>NEXT</a:t>
+            </a:r>
+          </a:p>
+          <a:p>
+            <a:r>
+              <a:t>The words, on a real table. Move on after a learner can explain the current example or required action.</a:t>
+            </a:r>
+          </a:p>
         </p:txBody>
       </p:sp>
       <p:sp>
@@ -825,8 +1184,8 @@
 </p:notes>
 </file>
 
-<file path=ppt/notesSlides/notesSlide14.xml><?xml version="1.0" encoding="utf-8"?>
-<p:notes xmlns:a="http://schemas.openxmlformats.org/drawingml/2006/main" xmlns:p="http://schemas.openxmlformats.org/presentationml/2006/main" xmlns:r="http://schemas.openxmlformats.org/officeDocument/2006/relationships">
+<file path=ppt/notesSlides/notesSlide12.xml><?xml version="1.0" encoding="utf-8"?>
+<p:notes xmlns:a="http://schemas.openxmlformats.org/drawingml/2006/main" xmlns:p="http://schemas.openxmlformats.org/presentationml/2006/main">
   <p:cSld>
     <p:spTree>
       <p:nvGrpSpPr>
@@ -870,7 +1229,117 @@
           <a:lstStyle/>
           <a:p>
             <a:r>
-              <a:t>Reference.</a:t>
+              <a:t>TEACHING PURPOSE</a:t>
+            </a:r>
+          </a:p>
+          <a:p>
+            <a:r>
+              <a:t>One table. Five words you will hear all term.</a:t>
+            </a:r>
+          </a:p>
+          <a:p>
+            <a:r>
+              <a:t/>
+            </a:r>
+          </a:p>
+          <a:p>
+            <a:r>
+              <a:t>CONNECT</a:t>
+            </a:r>
+          </a:p>
+          <a:p>
+            <a:r>
+              <a:t>Build on the preceding slide: The words, on a real table.</a:t>
+            </a:r>
+          </a:p>
+          <a:p>
+            <a:r>
+              <a:t/>
+            </a:r>
+          </a:p>
+          <a:p>
+            <a:r>
+              <a:t>LECTURER CUE</a:t>
+            </a:r>
+          </a:p>
+          <a:p>
+            <a:r>
+              <a:t>The first five real rows of orders.csv. Everything you already know about a spreadsheet still applies; the words change and one new idea, the primary key, arrives.</a:t>
+            </a:r>
+          </a:p>
+          <a:p>
+            <a:r>
+              <a:t/>
+            </a:r>
+          </a:p>
+          <a:p>
+            <a:r>
+              <a:t>EXPLAIN IN ORDINARY WORDS</a:t>
+            </a:r>
+          </a:p>
+          <a:p>
+            <a:r>
+              <a:t>Grain means what one row represents. A key identifies a row; a primary key may use more than one column. A join matches keys, and multiple matches can multiply rows.</a:t>
+            </a:r>
+          </a:p>
+          <a:p>
+            <a:r>
+              <a:t/>
+            </a:r>
+          </a:p>
+          <a:p>
+            <a:r>
+              <a:t>CHECK AND EXPECTED ANSWER</a:t>
+            </a:r>
+          </a:p>
+          <a:p>
+            <a:r>
+              <a:t>One order has two lines. After joining orders to lines, how many rows for it? Two. Summing a repeated order-level total would double-count.</a:t>
+            </a:r>
+          </a:p>
+          <a:p>
+            <a:r>
+              <a:t/>
+            </a:r>
+          </a:p>
+          <a:p>
+            <a:r>
+              <a:t>IF LEARNERS ARE STUCK</a:t>
+            </a:r>
+          </a:p>
+          <a:p>
+            <a:r>
+              <a:t>Write one example row from each table. Circle keys and trace each match. Aggregate to the intended grain and check counts and totals.</a:t>
+            </a:r>
+          </a:p>
+          <a:p>
+            <a:r>
+              <a:t/>
+            </a:r>
+          </a:p>
+          <a:p>
+            <a:r>
+              <a:t>READ THE VISUAL</a:t>
+            </a:r>
+          </a:p>
+          <a:p>
+            <a:r>
+              <a:t>Start with the title and labels. Read one row or mark aloud, including its unit. Let a learner read a second one before discussing the pattern. Do not infer a numerical value from an unlabelled drawing.</a:t>
+            </a:r>
+          </a:p>
+          <a:p>
+            <a:r>
+              <a:t/>
+            </a:r>
+          </a:p>
+          <a:p>
+            <a:r>
+              <a:t>NEXT</a:t>
+            </a:r>
+          </a:p>
+          <a:p>
+            <a:r>
+              <a:t>What you are working with for five weeks. Move on after a learner can explain the current example or required action.</a:t>
             </a:r>
           </a:p>
         </p:txBody>
@@ -895,8 +1364,8 @@
 </p:notes>
 </file>
 
-<file path=ppt/notesSlides/notesSlide15.xml><?xml version="1.0" encoding="utf-8"?>
-<p:notes xmlns:a="http://schemas.openxmlformats.org/drawingml/2006/main" xmlns:p="http://schemas.openxmlformats.org/presentationml/2006/main" xmlns:r="http://schemas.openxmlformats.org/officeDocument/2006/relationships">
+<file path=ppt/notesSlides/notesSlide13.xml><?xml version="1.0" encoding="utf-8"?>
+<p:notes xmlns:a="http://schemas.openxmlformats.org/drawingml/2006/main" xmlns:p="http://schemas.openxmlformats.org/presentationml/2006/main">
   <p:cSld>
     <p:spTree>
       <p:nvGrpSpPr>
@@ -940,7 +1409,87 @@
           <a:lstStyle/>
           <a:p>
             <a:r>
-              <a:t>Starting to compute before agreeing what was asked. It is the most expensive habit in the room and the cheapest to fix.</a:t>
+              <a:t>TEACHING PURPOSE</a:t>
+            </a:r>
+          </a:p>
+          <a:p>
+            <a:r>
+              <a:t>What you are working with for five weeks</a:t>
+            </a:r>
+          </a:p>
+          <a:p>
+            <a:r>
+              <a:t/>
+            </a:r>
+          </a:p>
+          <a:p>
+            <a:r>
+              <a:t>CONNECT</a:t>
+            </a:r>
+          </a:p>
+          <a:p>
+            <a:r>
+              <a:t>Build on the preceding slide: One table. Five words you will hear all term..</a:t>
+            </a:r>
+          </a:p>
+          <a:p>
+            <a:r>
+              <a:t/>
+            </a:r>
+          </a:p>
+          <a:p>
+            <a:r>
+              <a:t>EXPLAIN IN ORDINARY WORDS</a:t>
+            </a:r>
+          </a:p>
+          <a:p>
+            <a:r>
+              <a:t>A function is a named set of instructions. def defines it; a call runs it with inputs. Parameters are input names, arguments are supplied values, and return sends the result back.</a:t>
+            </a:r>
+          </a:p>
+          <a:p>
+            <a:r>
+              <a:t/>
+            </a:r>
+          </a:p>
+          <a:p>
+            <a:r>
+              <a:t>CHECK AND EXPECTED ANSWER</a:t>
+            </a:r>
+          </a:p>
+          <a:p>
+            <a:r>
+              <a:t>Does print(8) return the number 8 to the caller? No; it displays 8 and returns None. A function needing a numeric result should return it.</a:t>
+            </a:r>
+          </a:p>
+          <a:p>
+            <a:r>
+              <a:t/>
+            </a:r>
+          </a:p>
+          <a:p>
+            <a:r>
+              <a:t>IF LEARNERS ARE STUCK</a:t>
+            </a:r>
+          </a:p>
+          <a:p>
+            <a:r>
+              <a:t>Trace one call: bind input names, run the indented body, reach return, then put the returned result back into the calling expression.</a:t>
+            </a:r>
+          </a:p>
+          <a:p>
+            <a:r>
+              <a:t/>
+            </a:r>
+          </a:p>
+          <a:p>
+            <a:r>
+              <a:t>NEXT</a:t>
+            </a:r>
+          </a:p>
+          <a:p>
+            <a:r>
+              <a:t>How the five weeks go. Move on after a learner can explain the current example or required action.</a:t>
             </a:r>
           </a:p>
         </p:txBody>
@@ -965,8 +1514,8 @@
 </p:notes>
 </file>
 
-<file path=ppt/notesSlides/notesSlide16.xml><?xml version="1.0" encoding="utf-8"?>
-<p:notes xmlns:a="http://schemas.openxmlformats.org/drawingml/2006/main" xmlns:p="http://schemas.openxmlformats.org/presentationml/2006/main" xmlns:r="http://schemas.openxmlformats.org/officeDocument/2006/relationships">
+<file path=ppt/notesSlides/notesSlide14.xml><?xml version="1.0" encoding="utf-8"?>
+<p:notes xmlns:a="http://schemas.openxmlformats.org/drawingml/2006/main" xmlns:p="http://schemas.openxmlformats.org/presentationml/2006/main">
   <p:cSld>
     <p:spTree>
       <p:nvGrpSpPr>
@@ -1008,7 +1557,106 @@
         <p:txBody>
           <a:bodyPr/>
           <a:lstStyle/>
-          <a:p/>
+          <a:p>
+            <a:r>
+              <a:t>TEACHING PURPOSE</a:t>
+            </a:r>
+          </a:p>
+          <a:p>
+            <a:r>
+              <a:t>How the five weeks go</a:t>
+            </a:r>
+          </a:p>
+          <a:p>
+            <a:r>
+              <a:t/>
+            </a:r>
+          </a:p>
+          <a:p>
+            <a:r>
+              <a:t>CONNECT</a:t>
+            </a:r>
+          </a:p>
+          <a:p>
+            <a:r>
+              <a:t>Build on the preceding slide: What you are working with for five weeks.</a:t>
+            </a:r>
+          </a:p>
+          <a:p>
+            <a:r>
+              <a:t/>
+            </a:r>
+          </a:p>
+          <a:p>
+            <a:r>
+              <a:t>LECTURER CUE</a:t>
+            </a:r>
+          </a:p>
+          <a:p>
+            <a:r>
+              <a:t>Reference.</a:t>
+            </a:r>
+          </a:p>
+          <a:p>
+            <a:r>
+              <a:t/>
+            </a:r>
+          </a:p>
+          <a:p>
+            <a:r>
+              <a:t>EXPLAIN IN ORDINARY WORDS</a:t>
+            </a:r>
+          </a:p>
+          <a:p>
+            <a:r>
+              <a:t>Grain means what one row represents. A key identifies a row; a primary key may use more than one column. A join matches keys, and multiple matches can multiply rows.</a:t>
+            </a:r>
+          </a:p>
+          <a:p>
+            <a:r>
+              <a:t/>
+            </a:r>
+          </a:p>
+          <a:p>
+            <a:r>
+              <a:t>CHECK AND EXPECTED ANSWER</a:t>
+            </a:r>
+          </a:p>
+          <a:p>
+            <a:r>
+              <a:t>One order has two lines. After joining orders to lines, how many rows for it? Two. Summing a repeated order-level total would double-count.</a:t>
+            </a:r>
+          </a:p>
+          <a:p>
+            <a:r>
+              <a:t/>
+            </a:r>
+          </a:p>
+          <a:p>
+            <a:r>
+              <a:t>IF LEARNERS ARE STUCK</a:t>
+            </a:r>
+          </a:p>
+          <a:p>
+            <a:r>
+              <a:t>Write one example row from each table. Circle keys and trace each match. Aggregate to the intended grain and check counts and totals.</a:t>
+            </a:r>
+          </a:p>
+          <a:p>
+            <a:r>
+              <a:t/>
+            </a:r>
+          </a:p>
+          <a:p>
+            <a:r>
+              <a:t>NEXT</a:t>
+            </a:r>
+          </a:p>
+          <a:p>
+            <a:r>
+              <a:t>Starting to compute before agreeing what was asked. It is the most expensive habit in the room and the cheapest to fix.. Move on after a learner can explain the current example or required action.</a:t>
+            </a:r>
+          </a:p>
         </p:txBody>
       </p:sp>
       <p:sp>
@@ -1031,8 +1679,8 @@
 </p:notes>
 </file>
 
-<file path=ppt/notesSlides/notesSlide17.xml><?xml version="1.0" encoding="utf-8"?>
-<p:notes xmlns:a="http://schemas.openxmlformats.org/drawingml/2006/main" xmlns:p="http://schemas.openxmlformats.org/presentationml/2006/main" xmlns:r="http://schemas.openxmlformats.org/officeDocument/2006/relationships">
+<file path=ppt/notesSlides/notesSlide15.xml><?xml version="1.0" encoding="utf-8"?>
+<p:notes xmlns:a="http://schemas.openxmlformats.org/drawingml/2006/main" xmlns:p="http://schemas.openxmlformats.org/presentationml/2006/main">
   <p:cSld>
     <p:spTree>
       <p:nvGrpSpPr>
@@ -1074,7 +1722,61 @@
         <p:txBody>
           <a:bodyPr/>
           <a:lstStyle/>
-          <a:p/>
+          <a:p>
+            <a:r>
+              <a:t>TEACHING PURPOSE</a:t>
+            </a:r>
+          </a:p>
+          <a:p>
+            <a:r>
+              <a:t>Starting to compute before agreeing what was asked. It is the most expensive habit in the room and the cheapest to fix.</a:t>
+            </a:r>
+          </a:p>
+          <a:p>
+            <a:r>
+              <a:t/>
+            </a:r>
+          </a:p>
+          <a:p>
+            <a:r>
+              <a:t>CONNECT</a:t>
+            </a:r>
+          </a:p>
+          <a:p>
+            <a:r>
+              <a:t>Build on the preceding slide: How the five weeks go.</a:t>
+            </a:r>
+          </a:p>
+          <a:p>
+            <a:r>
+              <a:t/>
+            </a:r>
+          </a:p>
+          <a:p>
+            <a:r>
+              <a:t>LECTURER CUE</a:t>
+            </a:r>
+          </a:p>
+          <a:p>
+            <a:r>
+              <a:t>Starting to compute before agreeing what was asked. It is the most expensive habit in the room and the cheapest to fix.</a:t>
+            </a:r>
+          </a:p>
+          <a:p>
+            <a:r>
+              <a:t/>
+            </a:r>
+          </a:p>
+          <a:p>
+            <a:r>
+              <a:t>NEXT</a:t>
+            </a:r>
+          </a:p>
+          <a:p>
+            <a:r>
+              <a:t>Can you answer these?. Move on after a learner can explain the current example or required action.</a:t>
+            </a:r>
+          </a:p>
         </p:txBody>
       </p:sp>
       <p:sp>
@@ -1097,8 +1799,8 @@
 </p:notes>
 </file>
 
-<file path=ppt/notesSlides/notesSlide18.xml><?xml version="1.0" encoding="utf-8"?>
-<p:notes xmlns:a="http://schemas.openxmlformats.org/drawingml/2006/main" xmlns:p="http://schemas.openxmlformats.org/presentationml/2006/main" xmlns:r="http://schemas.openxmlformats.org/officeDocument/2006/relationships">
+<file path=ppt/notesSlides/notesSlide16.xml><?xml version="1.0" encoding="utf-8"?>
+<p:notes xmlns:a="http://schemas.openxmlformats.org/drawingml/2006/main" xmlns:p="http://schemas.openxmlformats.org/presentationml/2006/main">
   <p:cSld>
     <p:spTree>
       <p:nvGrpSpPr>
@@ -1142,7 +1844,157 @@
           <a:lstStyle/>
           <a:p>
             <a:r>
-              <a:t>Open the six course files in your spreadsheet. For each one, write down three things: what one row represents in a single sentence, how many rows there are, and which column could never repeat. Then take the three requests on your sheet and turn each into an answerable question.</a:t>
+              <a:t>TEACHING PURPOSE</a:t>
+            </a:r>
+          </a:p>
+          <a:p>
+            <a:r>
+              <a:t>Can you answer these?</a:t>
+            </a:r>
+          </a:p>
+          <a:p>
+            <a:r>
+              <a:t/>
+            </a:r>
+          </a:p>
+          <a:p>
+            <a:r>
+              <a:t>CONNECT</a:t>
+            </a:r>
+          </a:p>
+          <a:p>
+            <a:r>
+              <a:t>Build on the preceding slide: Starting to compute before agreeing what was asked. It is the most expensive habit in the room and the cheapest to fix..</a:t>
+            </a:r>
+          </a:p>
+          <a:p>
+            <a:r>
+              <a:t/>
+            </a:r>
+          </a:p>
+          <a:p>
+            <a:r>
+              <a:t>EXPLAIN IN ORDINARY WORDS</a:t>
+            </a:r>
+          </a:p>
+          <a:p>
+            <a:r>
+              <a:t>Missing means not recorded, not automatically zero. Decide why it is missing and document the rule. Fitted fill values must come from training data when evaluating a model.</a:t>
+            </a:r>
+          </a:p>
+          <a:p>
+            <a:r>
+              <a:t/>
+            </a:r>
+          </a:p>
+          <a:p>
+            <a:r>
+              <a:t>CHECK AND EXPECTED ANSWER</a:t>
+            </a:r>
+          </a:p>
+          <a:p>
+            <a:r>
+              <a:t>Is an unrecorded energy reading evidence of zero consumption? No.</a:t>
+            </a:r>
+          </a:p>
+          <a:p>
+            <a:r>
+              <a:t/>
+            </a:r>
+          </a:p>
+          <a:p>
+            <a:r>
+              <a:t>IF LEARNERS ARE STUCK</a:t>
+            </a:r>
+          </a:p>
+          <a:p>
+            <a:r>
+              <a:t>Use three rows: a recorded zero, a recorded positive value and a blank. Explain their different meanings before cleaning.</a:t>
+            </a:r>
+          </a:p>
+          <a:p>
+            <a:r>
+              <a:t/>
+            </a:r>
+          </a:p>
+          <a:p>
+            <a:r>
+              <a:t>DISCUSSION KEY FOR THIS SLIDE</a:t>
+            </a:r>
+          </a:p>
+          <a:p>
+            <a:r>
+              <a:t>ANSWERS</a:t>
+            </a:r>
+          </a:p>
+          <a:p>
+            <a:r>
+              <a:t>How did you do?</a:t>
+            </a:r>
+          </a:p>
+          <a:p>
+            <a:r>
+              <a:t>A</a:t>
+            </a:r>
+          </a:p>
+          <a:p>
+            <a:r>
+              <a:t>"The Eastern region is underperforming"</a:t>
+            </a:r>
+          </a:p>
+          <a:p>
+            <a:r>
+              <a:t>A number, a population and a window. Underperforming on what measure, against which comparison, over what period. As it stands it is a conclusion with no question underneath it.</a:t>
+            </a:r>
+          </a:p>
+          <a:p>
+            <a:r>
+              <a:t>B</a:t>
+            </a:r>
+          </a:p>
+          <a:p>
+            <a:r>
+              <a:t>Two answers to "how many customers"</a:t>
+            </a:r>
+          </a:p>
+          <a:p>
+            <a:r>
+              <a:t>Everyone in the customers table, which is 401 here, or everyone who placed an order in a given window, which is smaller. Both are right. Which one was wanted is the question you have to go and ask.</a:t>
+            </a:r>
+          </a:p>
+          <a:p>
+            <a:r>
+              <a:t>C</a:t>
+            </a:r>
+          </a:p>
+          <a:p>
+            <a:r>
+              <a:t>Different row counts in two tables</a:t>
+            </a:r>
+          </a:p>
+          <a:p>
+            <a:r>
+              <a:t>No. They have different GRAIN. One row of orders is one order; one row of order_items is one product on one order. Both tables are complete, and a total computed on the wrong one is wrong.</a:t>
+            </a:r>
+          </a:p>
+          <a:p>
+            <a:r>
+              <a:t>Let learners attempt first; use this to explain the reasoning, not just reveal the answer.</a:t>
+            </a:r>
+          </a:p>
+          <a:p>
+            <a:r>
+              <a:t/>
+            </a:r>
+          </a:p>
+          <a:p>
+            <a:r>
+              <a:t>NEXT</a:t>
+            </a:r>
+          </a:p>
+          <a:p>
+            <a:r>
+              <a:t>How did you do?. Move on after a learner can explain the current example or required action.</a:t>
             </a:r>
           </a:p>
         </p:txBody>
@@ -1167,8 +2019,8 @@
 </p:notes>
 </file>
 
-<file path=ppt/notesSlides/notesSlide19.xml><?xml version="1.0" encoding="utf-8"?>
-<p:notes xmlns:a="http://schemas.openxmlformats.org/drawingml/2006/main" xmlns:p="http://schemas.openxmlformats.org/presentationml/2006/main" xmlns:r="http://schemas.openxmlformats.org/officeDocument/2006/relationships">
+<file path=ppt/notesSlides/notesSlide17.xml><?xml version="1.0" encoding="utf-8"?>
+<p:notes xmlns:a="http://schemas.openxmlformats.org/drawingml/2006/main" xmlns:p="http://schemas.openxmlformats.org/presentationml/2006/main">
   <p:cSld>
     <p:spTree>
       <p:nvGrpSpPr>
@@ -1210,7 +2062,91 @@
         <p:txBody>
           <a:bodyPr/>
           <a:lstStyle/>
-          <a:p/>
+          <a:p>
+            <a:r>
+              <a:t>TEACHING PURPOSE</a:t>
+            </a:r>
+          </a:p>
+          <a:p>
+            <a:r>
+              <a:t>How did you do?</a:t>
+            </a:r>
+          </a:p>
+          <a:p>
+            <a:r>
+              <a:t/>
+            </a:r>
+          </a:p>
+          <a:p>
+            <a:r>
+              <a:t>CONNECT</a:t>
+            </a:r>
+          </a:p>
+          <a:p>
+            <a:r>
+              <a:t>Build on the preceding slide: Can you answer these?.</a:t>
+            </a:r>
+          </a:p>
+          <a:p>
+            <a:r>
+              <a:t/>
+            </a:r>
+          </a:p>
+          <a:p>
+            <a:r>
+              <a:t>EXPLAIN IN ORDINARY WORDS</a:t>
+            </a:r>
+          </a:p>
+          <a:p>
+            <a:r>
+              <a:t>Grain means what one row represents. A key identifies a row; a primary key may use more than one column. A join matches keys, and multiple matches can multiply rows.</a:t>
+            </a:r>
+          </a:p>
+          <a:p>
+            <a:r>
+              <a:t/>
+            </a:r>
+          </a:p>
+          <a:p>
+            <a:r>
+              <a:t>CHECK AND EXPECTED ANSWER</a:t>
+            </a:r>
+          </a:p>
+          <a:p>
+            <a:r>
+              <a:t>One order has two lines. After joining orders to lines, how many rows for it? Two. Summing a repeated order-level total would double-count.</a:t>
+            </a:r>
+          </a:p>
+          <a:p>
+            <a:r>
+              <a:t/>
+            </a:r>
+          </a:p>
+          <a:p>
+            <a:r>
+              <a:t>IF LEARNERS ARE STUCK</a:t>
+            </a:r>
+          </a:p>
+          <a:p>
+            <a:r>
+              <a:t>Write one example row from each table. Circle keys and trace each match. Aggregate to the intended grain and check counts and totals.</a:t>
+            </a:r>
+          </a:p>
+          <a:p>
+            <a:r>
+              <a:t/>
+            </a:r>
+          </a:p>
+          <a:p>
+            <a:r>
+              <a:t>NEXT</a:t>
+            </a:r>
+          </a:p>
+          <a:p>
+            <a:r>
+              <a:t>Say what one row is, six times. Move on after a learner can explain the current example or required action.</a:t>
+            </a:r>
+          </a:p>
         </p:txBody>
       </p:sp>
       <p:sp>
@@ -1233,8 +2169,8 @@
 </p:notes>
 </file>
 
-<file path=ppt/notesSlides/notesSlide2.xml><?xml version="1.0" encoding="utf-8"?>
-<p:notes xmlns:a="http://schemas.openxmlformats.org/drawingml/2006/main" xmlns:p="http://schemas.openxmlformats.org/presentationml/2006/main" xmlns:r="http://schemas.openxmlformats.org/officeDocument/2006/relationships">
+<file path=ppt/notesSlides/notesSlide18.xml><?xml version="1.0" encoding="utf-8"?>
+<p:notes xmlns:a="http://schemas.openxmlformats.org/drawingml/2006/main" xmlns:p="http://schemas.openxmlformats.org/presentationml/2006/main">
   <p:cSld>
     <p:spTree>
       <p:nvGrpSpPr>
@@ -1278,7 +2214,102 @@
           <a:lstStyle/>
           <a:p>
             <a:r>
-              <a:t>Tonight is session 1 of twelve.</a:t>
+              <a:t>TEACHING PURPOSE</a:t>
+            </a:r>
+          </a:p>
+          <a:p>
+            <a:r>
+              <a:t>Say what one row is, six times</a:t>
+            </a:r>
+          </a:p>
+          <a:p>
+            <a:r>
+              <a:t/>
+            </a:r>
+          </a:p>
+          <a:p>
+            <a:r>
+              <a:t>CONNECT</a:t>
+            </a:r>
+          </a:p>
+          <a:p>
+            <a:r>
+              <a:t>Build on the preceding slide: How did you do?.</a:t>
+            </a:r>
+          </a:p>
+          <a:p>
+            <a:r>
+              <a:t/>
+            </a:r>
+          </a:p>
+          <a:p>
+            <a:r>
+              <a:t>LECTURER CUE</a:t>
+            </a:r>
+          </a:p>
+          <a:p>
+            <a:r>
+              <a:t>Open the six course files in your spreadsheet. For each one, write down three things: what one row represents in a single sentence, how many rows there are, and which column could never repeat. Then take the three requests on your sheet and turn each into an answerable question.</a:t>
+            </a:r>
+          </a:p>
+          <a:p>
+            <a:r>
+              <a:t/>
+            </a:r>
+          </a:p>
+          <a:p>
+            <a:r>
+              <a:t>EXPLAIN IN ORDINARY WORDS</a:t>
+            </a:r>
+          </a:p>
+          <a:p>
+            <a:r>
+              <a:t>Grain means what one row represents. A key identifies a row; a primary key may use more than one column. A join matches keys, and multiple matches can multiply rows.</a:t>
+            </a:r>
+          </a:p>
+          <a:p>
+            <a:r>
+              <a:t/>
+            </a:r>
+          </a:p>
+          <a:p>
+            <a:r>
+              <a:t>CHECK AND EXPECTED ANSWER</a:t>
+            </a:r>
+          </a:p>
+          <a:p>
+            <a:r>
+              <a:t>One order has two lines. After joining orders to lines, how many rows for it? Two. Summing a repeated order-level total would double-count.</a:t>
+            </a:r>
+          </a:p>
+          <a:p>
+            <a:r>
+              <a:t/>
+            </a:r>
+          </a:p>
+          <a:p>
+            <a:r>
+              <a:t>IF LEARNERS ARE STUCK</a:t>
+            </a:r>
+          </a:p>
+          <a:p>
+            <a:r>
+              <a:t>Write one example row from each table. Circle keys and trace each match. Aggregate to the intended grain and check counts and totals.</a:t>
+            </a:r>
+          </a:p>
+          <a:p>
+            <a:r>
+              <a:t/>
+            </a:r>
+          </a:p>
+          <a:p>
+            <a:r>
+              <a:t>NEXT</a:t>
+            </a:r>
+          </a:p>
+          <a:p>
+            <a:r>
+              <a:t>What you can do now. Move on after a learner can explain the current example or required action.</a:t>
             </a:r>
           </a:p>
         </p:txBody>
@@ -1303,8 +2334,8 @@
 </p:notes>
 </file>
 
-<file path=ppt/notesSlides/notesSlide20.xml><?xml version="1.0" encoding="utf-8"?>
-<p:notes xmlns:a="http://schemas.openxmlformats.org/drawingml/2006/main" xmlns:p="http://schemas.openxmlformats.org/presentationml/2006/main" xmlns:r="http://schemas.openxmlformats.org/officeDocument/2006/relationships">
+<file path=ppt/notesSlides/notesSlide19.xml><?xml version="1.0" encoding="utf-8"?>
+<p:notes xmlns:a="http://schemas.openxmlformats.org/drawingml/2006/main" xmlns:p="http://schemas.openxmlformats.org/presentationml/2006/main">
   <p:cSld>
     <p:spTree>
       <p:nvGrpSpPr>
@@ -1348,7 +2379,87 @@
           <a:lstStyle/>
           <a:p>
             <a:r>
-              <a:t>Write down the last three things somebody asked you for at work. Rewrite each as a question with a number, a population and a window. Bring them: they are capstone candidates.</a:t>
+              <a:t>TEACHING PURPOSE</a:t>
+            </a:r>
+          </a:p>
+          <a:p>
+            <a:r>
+              <a:t>What you can do now</a:t>
+            </a:r>
+          </a:p>
+          <a:p>
+            <a:r>
+              <a:t/>
+            </a:r>
+          </a:p>
+          <a:p>
+            <a:r>
+              <a:t>CONNECT</a:t>
+            </a:r>
+          </a:p>
+          <a:p>
+            <a:r>
+              <a:t>Build on the preceding slide: Say what one row is, six times.</a:t>
+            </a:r>
+          </a:p>
+          <a:p>
+            <a:r>
+              <a:t/>
+            </a:r>
+          </a:p>
+          <a:p>
+            <a:r>
+              <a:t>EXPLAIN IN ORDINARY WORDS</a:t>
+            </a:r>
+          </a:p>
+          <a:p>
+            <a:r>
+              <a:t>An observation describes the data. A finding answers a defined question with evidence. A recommendation adds an action, its justification and limits.</a:t>
+            </a:r>
+          </a:p>
+          <a:p>
+            <a:r>
+              <a:t/>
+            </a:r>
+          </a:p>
+          <a:p>
+            <a:r>
+              <a:t>CHECK AND EXPECTED ANSWER</a:t>
+            </a:r>
+          </a:p>
+          <a:p>
+            <a:r>
+              <a:t>Does a difference between two groups prove one caused the other? No. Other differences or selection may explain it.</a:t>
+            </a:r>
+          </a:p>
+          <a:p>
+            <a:r>
+              <a:t/>
+            </a:r>
+          </a:p>
+          <a:p>
+            <a:r>
+              <a:t>IF LEARNERS ARE STUCK</a:t>
+            </a:r>
+          </a:p>
+          <a:p>
+            <a:r>
+              <a:t>Ask for the population, time period, number and comparison. Then ask what additional evidence could change the recommendation.</a:t>
+            </a:r>
+          </a:p>
+          <a:p>
+            <a:r>
+              <a:t/>
+            </a:r>
+          </a:p>
+          <a:p>
+            <a:r>
+              <a:t>NEXT</a:t>
+            </a:r>
+          </a:p>
+          <a:p>
+            <a:r>
+              <a:t>Before the next session. Move on after a learner can explain the current example or required action.</a:t>
             </a:r>
           </a:p>
         </p:txBody>
@@ -1373,8 +2484,8 @@
 </p:notes>
 </file>
 
-<file path=ppt/notesSlides/notesSlide21.xml><?xml version="1.0" encoding="utf-8"?>
-<p:notes xmlns:a="http://schemas.openxmlformats.org/drawingml/2006/main" xmlns:p="http://schemas.openxmlformats.org/presentationml/2006/main" xmlns:r="http://schemas.openxmlformats.org/officeDocument/2006/relationships">
+<file path=ppt/notesSlides/notesSlide2.xml><?xml version="1.0" encoding="utf-8"?>
+<p:notes xmlns:a="http://schemas.openxmlformats.org/drawingml/2006/main" xmlns:p="http://schemas.openxmlformats.org/presentationml/2006/main">
   <p:cSld>
     <p:spTree>
       <p:nvGrpSpPr>
@@ -1418,7 +2529,102 @@
           <a:lstStyle/>
           <a:p>
             <a:r>
-              <a:t>Everything from here is technique, and technique is teachable in five weeks. Knowing what you are being asked, and what one row means, is the part that separates an analyst from somebody who produces charts.</a:t>
+              <a:t>TEACHING PURPOSE</a:t>
+            </a:r>
+          </a:p>
+          <a:p>
+            <a:r>
+              <a:t>Where tonight sits</a:t>
+            </a:r>
+          </a:p>
+          <a:p>
+            <a:r>
+              <a:t/>
+            </a:r>
+          </a:p>
+          <a:p>
+            <a:r>
+              <a:t>CONNECT</a:t>
+            </a:r>
+          </a:p>
+          <a:p>
+            <a:r>
+              <a:t>Build on the preceding slide: From a spreadsheet to data.</a:t>
+            </a:r>
+          </a:p>
+          <a:p>
+            <a:r>
+              <a:t/>
+            </a:r>
+          </a:p>
+          <a:p>
+            <a:r>
+              <a:t>LECTURER CUE</a:t>
+            </a:r>
+          </a:p>
+          <a:p>
+            <a:r>
+              <a:t>Tonight is session 1 of fifteen.</a:t>
+            </a:r>
+          </a:p>
+          <a:p>
+            <a:r>
+              <a:t/>
+            </a:r>
+          </a:p>
+          <a:p>
+            <a:r>
+              <a:t>EXPLAIN IN ORDINARY WORDS</a:t>
+            </a:r>
+          </a:p>
+          <a:p>
+            <a:r>
+              <a:t>Grain means what one row represents. A key identifies a row; a primary key may use more than one column. A join matches keys, and multiple matches can multiply rows.</a:t>
+            </a:r>
+          </a:p>
+          <a:p>
+            <a:r>
+              <a:t/>
+            </a:r>
+          </a:p>
+          <a:p>
+            <a:r>
+              <a:t>CHECK AND EXPECTED ANSWER</a:t>
+            </a:r>
+          </a:p>
+          <a:p>
+            <a:r>
+              <a:t>One order has two lines. After joining orders to lines, how many rows for it? Two. Summing a repeated order-level total would double-count.</a:t>
+            </a:r>
+          </a:p>
+          <a:p>
+            <a:r>
+              <a:t/>
+            </a:r>
+          </a:p>
+          <a:p>
+            <a:r>
+              <a:t>IF LEARNERS ARE STUCK</a:t>
+            </a:r>
+          </a:p>
+          <a:p>
+            <a:r>
+              <a:t>Write one example row from each table. Circle keys and trace each match. Aggregate to the intended grain and check counts and totals.</a:t>
+            </a:r>
+          </a:p>
+          <a:p>
+            <a:r>
+              <a:t/>
+            </a:r>
+          </a:p>
+          <a:p>
+            <a:r>
+              <a:t>NEXT</a:t>
+            </a:r>
+          </a:p>
+          <a:p>
+            <a:r>
+              <a:t>The words for tonight. Move on after a learner can explain the current example or required action.</a:t>
             </a:r>
           </a:p>
         </p:txBody>
@@ -1443,8 +2649,8 @@
 </p:notes>
 </file>
 
-<file path=ppt/notesSlides/notesSlide3.xml><?xml version="1.0" encoding="utf-8"?>
-<p:notes xmlns:a="http://schemas.openxmlformats.org/drawingml/2006/main" xmlns:p="http://schemas.openxmlformats.org/presentationml/2006/main" xmlns:r="http://schemas.openxmlformats.org/officeDocument/2006/relationships">
+<file path=ppt/notesSlides/notesSlide20.xml><?xml version="1.0" encoding="utf-8"?>
+<p:notes xmlns:a="http://schemas.openxmlformats.org/drawingml/2006/main" xmlns:p="http://schemas.openxmlformats.org/presentationml/2006/main">
   <p:cSld>
     <p:spTree>
       <p:nvGrpSpPr>
@@ -1486,7 +2692,106 @@
         <p:txBody>
           <a:bodyPr/>
           <a:lstStyle/>
-          <a:p/>
+          <a:p>
+            <a:r>
+              <a:t>TEACHING PURPOSE</a:t>
+            </a:r>
+          </a:p>
+          <a:p>
+            <a:r>
+              <a:t>Before the next session</a:t>
+            </a:r>
+          </a:p>
+          <a:p>
+            <a:r>
+              <a:t/>
+            </a:r>
+          </a:p>
+          <a:p>
+            <a:r>
+              <a:t>CONNECT</a:t>
+            </a:r>
+          </a:p>
+          <a:p>
+            <a:r>
+              <a:t>Build on the preceding slide: What you can do now.</a:t>
+            </a:r>
+          </a:p>
+          <a:p>
+            <a:r>
+              <a:t/>
+            </a:r>
+          </a:p>
+          <a:p>
+            <a:r>
+              <a:t>LECTURER CUE</a:t>
+            </a:r>
+          </a:p>
+          <a:p>
+            <a:r>
+              <a:t>Write down the last three things somebody asked you for at work. Rewrite each as a question with a number, a population and a window. Bring them: they are capstone candidates.</a:t>
+            </a:r>
+          </a:p>
+          <a:p>
+            <a:r>
+              <a:t/>
+            </a:r>
+          </a:p>
+          <a:p>
+            <a:r>
+              <a:t>EXPLAIN IN ORDINARY WORDS</a:t>
+            </a:r>
+          </a:p>
+          <a:p>
+            <a:r>
+              <a:t>An observation describes the data. A finding answers a defined question with evidence. A recommendation adds an action, its justification and limits.</a:t>
+            </a:r>
+          </a:p>
+          <a:p>
+            <a:r>
+              <a:t/>
+            </a:r>
+          </a:p>
+          <a:p>
+            <a:r>
+              <a:t>CHECK AND EXPECTED ANSWER</a:t>
+            </a:r>
+          </a:p>
+          <a:p>
+            <a:r>
+              <a:t>Does a difference between two groups prove one caused the other? No. Other differences or selection may explain it.</a:t>
+            </a:r>
+          </a:p>
+          <a:p>
+            <a:r>
+              <a:t/>
+            </a:r>
+          </a:p>
+          <a:p>
+            <a:r>
+              <a:t>IF LEARNERS ARE STUCK</a:t>
+            </a:r>
+          </a:p>
+          <a:p>
+            <a:r>
+              <a:t>Ask for the population, time period, number and comparison. Then ask what additional evidence could change the recommendation.</a:t>
+            </a:r>
+          </a:p>
+          <a:p>
+            <a:r>
+              <a:t/>
+            </a:r>
+          </a:p>
+          <a:p>
+            <a:r>
+              <a:t>NEXT</a:t>
+            </a:r>
+          </a:p>
+          <a:p>
+            <a:r>
+              <a:t>You now have a question, and the words to describe the data. Move on after a learner can explain the current example or required action.</a:t>
+            </a:r>
+          </a:p>
         </p:txBody>
       </p:sp>
       <p:sp>
@@ -1509,8 +2814,8 @@
 </p:notes>
 </file>
 
-<file path=ppt/notesSlides/notesSlide4.xml><?xml version="1.0" encoding="utf-8"?>
-<p:notes xmlns:a="http://schemas.openxmlformats.org/drawingml/2006/main" xmlns:p="http://schemas.openxmlformats.org/presentationml/2006/main" xmlns:r="http://schemas.openxmlformats.org/officeDocument/2006/relationships">
+<file path=ppt/notesSlides/notesSlide21.xml><?xml version="1.0" encoding="utf-8"?>
+<p:notes xmlns:a="http://schemas.openxmlformats.org/drawingml/2006/main" xmlns:p="http://schemas.openxmlformats.org/presentationml/2006/main">
   <p:cSld>
     <p:spTree>
       <p:nvGrpSpPr>
@@ -1554,7 +2859,87 @@
           <a:lstStyle/>
           <a:p>
             <a:r>
-              <a:t>These three are what tonight is marked against, in the sense that the lab checks them.</a:t>
+              <a:t>TEACHING PURPOSE</a:t>
+            </a:r>
+          </a:p>
+          <a:p>
+            <a:r>
+              <a:t>You now have a question, and the words to describe the data</a:t>
+            </a:r>
+          </a:p>
+          <a:p>
+            <a:r>
+              <a:t/>
+            </a:r>
+          </a:p>
+          <a:p>
+            <a:r>
+              <a:t>CONNECT</a:t>
+            </a:r>
+          </a:p>
+          <a:p>
+            <a:r>
+              <a:t>Build on the preceding slide: Before the next session.</a:t>
+            </a:r>
+          </a:p>
+          <a:p>
+            <a:r>
+              <a:t/>
+            </a:r>
+          </a:p>
+          <a:p>
+            <a:r>
+              <a:t>LECTURER CUE</a:t>
+            </a:r>
+          </a:p>
+          <a:p>
+            <a:r>
+              <a:t>Everything from here is technique, and technique is teachable in five weeks. Knowing what you are being asked, and what one row means, is the part that separates an analyst from somebody who produces charts.</a:t>
+            </a:r>
+          </a:p>
+          <a:p>
+            <a:r>
+              <a:t/>
+            </a:r>
+          </a:p>
+          <a:p>
+            <a:r>
+              <a:t>EXPLAIN IN ORDINARY WORDS</a:t>
+            </a:r>
+          </a:p>
+          <a:p>
+            <a:r>
+              <a:t>An observation describes the data. A finding answers a defined question with evidence. A recommendation adds an action, its justification and limits.</a:t>
+            </a:r>
+          </a:p>
+          <a:p>
+            <a:r>
+              <a:t/>
+            </a:r>
+          </a:p>
+          <a:p>
+            <a:r>
+              <a:t>CHECK AND EXPECTED ANSWER</a:t>
+            </a:r>
+          </a:p>
+          <a:p>
+            <a:r>
+              <a:t>Does a difference between two groups prove one caused the other? No. Other differences or selection may explain it.</a:t>
+            </a:r>
+          </a:p>
+          <a:p>
+            <a:r>
+              <a:t/>
+            </a:r>
+          </a:p>
+          <a:p>
+            <a:r>
+              <a:t>IF LEARNERS ARE STUCK</a:t>
+            </a:r>
+          </a:p>
+          <a:p>
+            <a:r>
+              <a:t>Ask for the population, time period, number and comparison. Then ask what additional evidence could change the recommendation.</a:t>
             </a:r>
           </a:p>
         </p:txBody>
@@ -1579,8 +2964,8 @@
 </p:notes>
 </file>
 
-<file path=ppt/notesSlides/notesSlide5.xml><?xml version="1.0" encoding="utf-8"?>
-<p:notes xmlns:a="http://schemas.openxmlformats.org/drawingml/2006/main" xmlns:p="http://schemas.openxmlformats.org/presentationml/2006/main" xmlns:r="http://schemas.openxmlformats.org/officeDocument/2006/relationships">
+<file path=ppt/notesSlides/notesSlide3.xml><?xml version="1.0" encoding="utf-8"?>
+<p:notes xmlns:a="http://schemas.openxmlformats.org/drawingml/2006/main" xmlns:p="http://schemas.openxmlformats.org/presentationml/2006/main">
   <p:cSld>
     <p:spTree>
       <p:nvGrpSpPr>
@@ -1624,7 +3009,87 @@
           <a:lstStyle/>
           <a:p>
             <a:r>
-              <a:t>Most bad analysis is not a technique failure. It is a correct answer to a question nobody asked.</a:t>
+              <a:t>TEACHING PURPOSE</a:t>
+            </a:r>
+          </a:p>
+          <a:p>
+            <a:r>
+              <a:t>The words for tonight</a:t>
+            </a:r>
+          </a:p>
+          <a:p>
+            <a:r>
+              <a:t/>
+            </a:r>
+          </a:p>
+          <a:p>
+            <a:r>
+              <a:t>CONNECT</a:t>
+            </a:r>
+          </a:p>
+          <a:p>
+            <a:r>
+              <a:t>Build on the preceding slide: Where tonight sits.</a:t>
+            </a:r>
+          </a:p>
+          <a:p>
+            <a:r>
+              <a:t/>
+            </a:r>
+          </a:p>
+          <a:p>
+            <a:r>
+              <a:t>EXPLAIN IN ORDINARY WORDS</a:t>
+            </a:r>
+          </a:p>
+          <a:p>
+            <a:r>
+              <a:t>Grain means what one row represents. A key identifies a row; a primary key may use more than one column. A join matches keys, and multiple matches can multiply rows.</a:t>
+            </a:r>
+          </a:p>
+          <a:p>
+            <a:r>
+              <a:t/>
+            </a:r>
+          </a:p>
+          <a:p>
+            <a:r>
+              <a:t>CHECK AND EXPECTED ANSWER</a:t>
+            </a:r>
+          </a:p>
+          <a:p>
+            <a:r>
+              <a:t>One order has two lines. After joining orders to lines, how many rows for it? Two. Summing a repeated order-level total would double-count.</a:t>
+            </a:r>
+          </a:p>
+          <a:p>
+            <a:r>
+              <a:t/>
+            </a:r>
+          </a:p>
+          <a:p>
+            <a:r>
+              <a:t>IF LEARNERS ARE STUCK</a:t>
+            </a:r>
+          </a:p>
+          <a:p>
+            <a:r>
+              <a:t>Write one example row from each table. Circle keys and trace each match. Aggregate to the intended grain and check counts and totals.</a:t>
+            </a:r>
+          </a:p>
+          <a:p>
+            <a:r>
+              <a:t/>
+            </a:r>
+          </a:p>
+          <a:p>
+            <a:r>
+              <a:t>NEXT</a:t>
+            </a:r>
+          </a:p>
+          <a:p>
+            <a:r>
+              <a:t>By the end of tonight you can…. Move on after a learner can explain the current example or required action.</a:t>
             </a:r>
           </a:p>
         </p:txBody>
@@ -1649,8 +3114,8 @@
 </p:notes>
 </file>
 
-<file path=ppt/notesSlides/notesSlide6.xml><?xml version="1.0" encoding="utf-8"?>
-<p:notes xmlns:a="http://schemas.openxmlformats.org/drawingml/2006/main" xmlns:p="http://schemas.openxmlformats.org/presentationml/2006/main" xmlns:r="http://schemas.openxmlformats.org/officeDocument/2006/relationships">
+<file path=ppt/notesSlides/notesSlide4.xml><?xml version="1.0" encoding="utf-8"?>
+<p:notes xmlns:a="http://schemas.openxmlformats.org/drawingml/2006/main" xmlns:p="http://schemas.openxmlformats.org/presentationml/2006/main">
   <p:cSld>
     <p:spTree>
       <p:nvGrpSpPr>
@@ -1692,7 +3157,106 @@
         <p:txBody>
           <a:bodyPr/>
           <a:lstStyle/>
-          <a:p/>
+          <a:p>
+            <a:r>
+              <a:t>TEACHING PURPOSE</a:t>
+            </a:r>
+          </a:p>
+          <a:p>
+            <a:r>
+              <a:t>By the end of tonight you can…</a:t>
+            </a:r>
+          </a:p>
+          <a:p>
+            <a:r>
+              <a:t/>
+            </a:r>
+          </a:p>
+          <a:p>
+            <a:r>
+              <a:t>CONNECT</a:t>
+            </a:r>
+          </a:p>
+          <a:p>
+            <a:r>
+              <a:t>Build on the preceding slide: The words for tonight.</a:t>
+            </a:r>
+          </a:p>
+          <a:p>
+            <a:r>
+              <a:t/>
+            </a:r>
+          </a:p>
+          <a:p>
+            <a:r>
+              <a:t>LECTURER CUE</a:t>
+            </a:r>
+          </a:p>
+          <a:p>
+            <a:r>
+              <a:t>These three are what tonight is marked against, in the sense that the lab checks them.</a:t>
+            </a:r>
+          </a:p>
+          <a:p>
+            <a:r>
+              <a:t/>
+            </a:r>
+          </a:p>
+          <a:p>
+            <a:r>
+              <a:t>EXPLAIN IN ORDINARY WORDS</a:t>
+            </a:r>
+          </a:p>
+          <a:p>
+            <a:r>
+              <a:t>An observation describes the data. A finding answers a defined question with evidence. A recommendation adds an action, its justification and limits.</a:t>
+            </a:r>
+          </a:p>
+          <a:p>
+            <a:r>
+              <a:t/>
+            </a:r>
+          </a:p>
+          <a:p>
+            <a:r>
+              <a:t>CHECK AND EXPECTED ANSWER</a:t>
+            </a:r>
+          </a:p>
+          <a:p>
+            <a:r>
+              <a:t>Does a difference between two groups prove one caused the other? No. Other differences or selection may explain it.</a:t>
+            </a:r>
+          </a:p>
+          <a:p>
+            <a:r>
+              <a:t/>
+            </a:r>
+          </a:p>
+          <a:p>
+            <a:r>
+              <a:t>IF LEARNERS ARE STUCK</a:t>
+            </a:r>
+          </a:p>
+          <a:p>
+            <a:r>
+              <a:t>Ask for the population, time period, number and comparison. Then ask what additional evidence could change the recommendation.</a:t>
+            </a:r>
+          </a:p>
+          <a:p>
+            <a:r>
+              <a:t/>
+            </a:r>
+          </a:p>
+          <a:p>
+            <a:r>
+              <a:t>NEXT</a:t>
+            </a:r>
+          </a:p>
+          <a:p>
+            <a:r>
+              <a:t>What is the difference between what you were asked. Move on after a learner can explain the current example or required action.</a:t>
+            </a:r>
+          </a:p>
         </p:txBody>
       </p:sp>
       <p:sp>
@@ -1715,8 +3279,8 @@
 </p:notes>
 </file>
 
-<file path=ppt/notesSlides/notesSlide7.xml><?xml version="1.0" encoding="utf-8"?>
-<p:notes xmlns:a="http://schemas.openxmlformats.org/drawingml/2006/main" xmlns:p="http://schemas.openxmlformats.org/presentationml/2006/main" xmlns:r="http://schemas.openxmlformats.org/officeDocument/2006/relationships">
+<file path=ppt/notesSlides/notesSlide5.xml><?xml version="1.0" encoding="utf-8"?>
+<p:notes xmlns:a="http://schemas.openxmlformats.org/drawingml/2006/main" xmlns:p="http://schemas.openxmlformats.org/presentationml/2006/main">
   <p:cSld>
     <p:spTree>
       <p:nvGrpSpPr>
@@ -1758,7 +3322,106 @@
         <p:txBody>
           <a:bodyPr/>
           <a:lstStyle/>
-          <a:p/>
+          <a:p>
+            <a:r>
+              <a:t>TEACHING PURPOSE</a:t>
+            </a:r>
+          </a:p>
+          <a:p>
+            <a:r>
+              <a:t>What is the difference between what you were asked</a:t>
+            </a:r>
+          </a:p>
+          <a:p>
+            <a:r>
+              <a:t/>
+            </a:r>
+          </a:p>
+          <a:p>
+            <a:r>
+              <a:t>CONNECT</a:t>
+            </a:r>
+          </a:p>
+          <a:p>
+            <a:r>
+              <a:t>Build on the preceding slide: By the end of tonight you can….</a:t>
+            </a:r>
+          </a:p>
+          <a:p>
+            <a:r>
+              <a:t/>
+            </a:r>
+          </a:p>
+          <a:p>
+            <a:r>
+              <a:t>LECTURER CUE</a:t>
+            </a:r>
+          </a:p>
+          <a:p>
+            <a:r>
+              <a:t>Most bad analysis is not a technique failure. It is a correct answer to a question nobody asked.</a:t>
+            </a:r>
+          </a:p>
+          <a:p>
+            <a:r>
+              <a:t/>
+            </a:r>
+          </a:p>
+          <a:p>
+            <a:r>
+              <a:t>EXPLAIN IN ORDINARY WORDS</a:t>
+            </a:r>
+          </a:p>
+          <a:p>
+            <a:r>
+              <a:t>An observation describes the data. A finding answers a defined question with evidence. A recommendation adds an action, its justification and limits.</a:t>
+            </a:r>
+          </a:p>
+          <a:p>
+            <a:r>
+              <a:t/>
+            </a:r>
+          </a:p>
+          <a:p>
+            <a:r>
+              <a:t>CHECK AND EXPECTED ANSWER</a:t>
+            </a:r>
+          </a:p>
+          <a:p>
+            <a:r>
+              <a:t>Does a difference between two groups prove one caused the other? No. Other differences or selection may explain it.</a:t>
+            </a:r>
+          </a:p>
+          <a:p>
+            <a:r>
+              <a:t/>
+            </a:r>
+          </a:p>
+          <a:p>
+            <a:r>
+              <a:t>IF LEARNERS ARE STUCK</a:t>
+            </a:r>
+          </a:p>
+          <a:p>
+            <a:r>
+              <a:t>Ask for the population, time period, number and comparison. Then ask what additional evidence could change the recommendation.</a:t>
+            </a:r>
+          </a:p>
+          <a:p>
+            <a:r>
+              <a:t/>
+            </a:r>
+          </a:p>
+          <a:p>
+            <a:r>
+              <a:t>NEXT</a:t>
+            </a:r>
+          </a:p>
+          <a:p>
+            <a:r>
+              <a:t>What you were asked, and what you can answer. Move on after a learner can explain the current example or required action.</a:t>
+            </a:r>
+          </a:p>
         </p:txBody>
       </p:sp>
       <p:sp>
@@ -1781,8 +3444,8 @@
 </p:notes>
 </file>
 
-<file path=ppt/notesSlides/notesSlide8.xml><?xml version="1.0" encoding="utf-8"?>
-<p:notes xmlns:a="http://schemas.openxmlformats.org/drawingml/2006/main" xmlns:p="http://schemas.openxmlformats.org/presentationml/2006/main" xmlns:r="http://schemas.openxmlformats.org/officeDocument/2006/relationships">
+<file path=ppt/notesSlides/notesSlide6.xml><?xml version="1.0" encoding="utf-8"?>
+<p:notes xmlns:a="http://schemas.openxmlformats.org/drawingml/2006/main" xmlns:p="http://schemas.openxmlformats.org/presentationml/2006/main">
   <p:cSld>
     <p:spTree>
       <p:nvGrpSpPr>
@@ -1826,7 +3489,87 @@
           <a:lstStyle/>
           <a:p>
             <a:r>
-              <a:t>A question with three things attached: a NUMBER you will produce, a POPULATION it covers, and a TIME WINDOW. Without all three, two people can agree on the answer and still disagree about what it meant.</a:t>
+              <a:t>TEACHING PURPOSE</a:t>
+            </a:r>
+          </a:p>
+          <a:p>
+            <a:r>
+              <a:t>Four requests, as they actually arrive</a:t>
+            </a:r>
+          </a:p>
+          <a:p>
+            <a:r>
+              <a:t/>
+            </a:r>
+          </a:p>
+          <a:p>
+            <a:r>
+              <a:t>CONNECT</a:t>
+            </a:r>
+          </a:p>
+          <a:p>
+            <a:r>
+              <a:t>Build on the preceding slide: What you were asked, and what you can answer.</a:t>
+            </a:r>
+          </a:p>
+          <a:p>
+            <a:r>
+              <a:t/>
+            </a:r>
+          </a:p>
+          <a:p>
+            <a:r>
+              <a:t>EXPLAIN IN ORDINARY WORDS</a:t>
+            </a:r>
+          </a:p>
+          <a:p>
+            <a:r>
+              <a:t>Read each quantity and unit before using a formula. Python calculates numbers but does not enforce physical units. Parentheses specify which operation happens first.</a:t>
+            </a:r>
+          </a:p>
+          <a:p>
+            <a:r>
+              <a:t/>
+            </a:r>
+          </a:p>
+          <a:p>
+            <a:r>
+              <a:t>CHECK AND EXPECTED ANSWER</a:t>
+            </a:r>
+          </a:p>
+          <a:p>
+            <a:r>
+              <a:t>What is 5 m times 3 m? 15 square metres. What is 7/2 in Python? 3.5; 7//2 is 3.</a:t>
+            </a:r>
+          </a:p>
+          <a:p>
+            <a:r>
+              <a:t/>
+            </a:r>
+          </a:p>
+          <a:p>
+            <a:r>
+              <a:t>IF LEARNERS ARE STUCK</a:t>
+            </a:r>
+          </a:p>
+          <a:p>
+            <a:r>
+              <a:t>Write the formula and units on paper, substitute small values, then translate it to Python. Check zero denominators and the issued sign convention.</a:t>
+            </a:r>
+          </a:p>
+          <a:p>
+            <a:r>
+              <a:t/>
+            </a:r>
+          </a:p>
+          <a:p>
+            <a:r>
+              <a:t>NEXT</a:t>
+            </a:r>
+          </a:p>
+          <a:p>
+            <a:r>
+              <a:t>You are not starting from nothing. Move on after a learner can explain the current example or required action.</a:t>
             </a:r>
           </a:p>
         </p:txBody>
@@ -1851,8 +3594,8 @@
 </p:notes>
 </file>
 
-<file path=ppt/notesSlides/notesSlide9.xml><?xml version="1.0" encoding="utf-8"?>
-<p:notes xmlns:a="http://schemas.openxmlformats.org/drawingml/2006/main" xmlns:p="http://schemas.openxmlformats.org/presentationml/2006/main" xmlns:r="http://schemas.openxmlformats.org/officeDocument/2006/relationships">
+<file path=ppt/notesSlides/notesSlide7.xml><?xml version="1.0" encoding="utf-8"?>
+<p:notes xmlns:a="http://schemas.openxmlformats.org/drawingml/2006/main" xmlns:p="http://schemas.openxmlformats.org/presentationml/2006/main">
   <p:cSld>
     <p:spTree>
       <p:nvGrpSpPr>
@@ -1896,7 +3639,417 @@
           <a:lstStyle/>
           <a:p>
             <a:r>
+              <a:t>TEACHING PURPOSE</a:t>
+            </a:r>
+          </a:p>
+          <a:p>
+            <a:r>
+              <a:t>You are not starting from nothing</a:t>
+            </a:r>
+          </a:p>
+          <a:p>
+            <a:r>
+              <a:t/>
+            </a:r>
+          </a:p>
+          <a:p>
+            <a:r>
+              <a:t>CONNECT</a:t>
+            </a:r>
+          </a:p>
+          <a:p>
+            <a:r>
+              <a:t>Build on the preceding slide: Four requests, as they actually arrive.</a:t>
+            </a:r>
+          </a:p>
+          <a:p>
+            <a:r>
+              <a:t/>
+            </a:r>
+          </a:p>
+          <a:p>
+            <a:r>
+              <a:t>EXPLAIN IN ORDINARY WORDS</a:t>
+            </a:r>
+          </a:p>
+          <a:p>
+            <a:r>
+              <a:t>Grain means what one row represents. A key identifies a row; a primary key may use more than one column. A join matches keys, and multiple matches can multiply rows.</a:t>
+            </a:r>
+          </a:p>
+          <a:p>
+            <a:r>
+              <a:t/>
+            </a:r>
+          </a:p>
+          <a:p>
+            <a:r>
+              <a:t>CHECK AND EXPECTED ANSWER</a:t>
+            </a:r>
+          </a:p>
+          <a:p>
+            <a:r>
+              <a:t>One order has two lines. After joining orders to lines, how many rows for it? Two. Summing a repeated order-level total would double-count.</a:t>
+            </a:r>
+          </a:p>
+          <a:p>
+            <a:r>
+              <a:t/>
+            </a:r>
+          </a:p>
+          <a:p>
+            <a:r>
+              <a:t>IF LEARNERS ARE STUCK</a:t>
+            </a:r>
+          </a:p>
+          <a:p>
+            <a:r>
+              <a:t>Write one example row from each table. Circle keys and trace each match. Aggregate to the intended grain and check counts and totals.</a:t>
+            </a:r>
+          </a:p>
+          <a:p>
+            <a:r>
+              <a:t/>
+            </a:r>
+          </a:p>
+          <a:p>
+            <a:r>
+              <a:t>NEXT</a:t>
+            </a:r>
+          </a:p>
+          <a:p>
+            <a:r>
+              <a:t>An answerable question. Move on after a learner can explain the current example or required action.</a:t>
+            </a:r>
+          </a:p>
+        </p:txBody>
+      </p:sp>
+      <p:sp>
+        <p:nvSpPr>
+          <p:cNvPr id="4" name="Slide Number Placeholder 3"/>
+          <p:cNvSpPr>
+            <a:spLocks noGrp="1"/>
+          </p:cNvSpPr>
+          <p:nvPr>
+            <p:ph type="sldNum" idx="5" sz="quarter"/>
+          </p:nvPr>
+        </p:nvSpPr>
+        <p:spPr/>
+      </p:sp>
+    </p:spTree>
+  </p:cSld>
+  <p:clrMapOvr>
+    <a:masterClrMapping/>
+  </p:clrMapOvr>
+</p:notes>
+</file>
+
+<file path=ppt/notesSlides/notesSlide8.xml><?xml version="1.0" encoding="utf-8"?>
+<p:notes xmlns:a="http://schemas.openxmlformats.org/drawingml/2006/main" xmlns:p="http://schemas.openxmlformats.org/presentationml/2006/main">
+  <p:cSld>
+    <p:spTree>
+      <p:nvGrpSpPr>
+        <p:cNvPr id="1" name=""/>
+        <p:cNvGrpSpPr/>
+        <p:nvPr/>
+      </p:nvGrpSpPr>
+      <p:grpSpPr>
+        <a:xfrm>
+          <a:off x="0" y="0"/>
+          <a:ext cx="0" cy="0"/>
+          <a:chOff x="0" y="0"/>
+          <a:chExt cx="0" cy="0"/>
+        </a:xfrm>
+      </p:grpSpPr>
+      <p:sp>
+        <p:nvSpPr>
+          <p:cNvPr id="2" name="Slide Image Placeholder 1"/>
+          <p:cNvSpPr>
+            <a:spLocks noGrp="1"/>
+          </p:cNvSpPr>
+          <p:nvPr>
+            <p:ph type="sldImg" idx="2"/>
+          </p:nvPr>
+        </p:nvSpPr>
+        <p:spPr/>
+      </p:sp>
+      <p:sp>
+        <p:nvSpPr>
+          <p:cNvPr id="3" name="Notes Placeholder 2"/>
+          <p:cNvSpPr>
+            <a:spLocks noGrp="1"/>
+          </p:cNvSpPr>
+          <p:nvPr>
+            <p:ph type="body" idx="3" sz="quarter"/>
+          </p:nvPr>
+        </p:nvSpPr>
+        <p:spPr/>
+        <p:txBody>
+          <a:bodyPr/>
+          <a:lstStyle/>
+          <a:p>
+            <a:r>
+              <a:t>TEACHING PURPOSE</a:t>
+            </a:r>
+          </a:p>
+          <a:p>
+            <a:r>
+              <a:t>An answerable question</a:t>
+            </a:r>
+          </a:p>
+          <a:p>
+            <a:r>
+              <a:t/>
+            </a:r>
+          </a:p>
+          <a:p>
+            <a:r>
+              <a:t>CONNECT</a:t>
+            </a:r>
+          </a:p>
+          <a:p>
+            <a:r>
+              <a:t>Build on the preceding slide: You are not starting from nothing.</a:t>
+            </a:r>
+          </a:p>
+          <a:p>
+            <a:r>
+              <a:t/>
+            </a:r>
+          </a:p>
+          <a:p>
+            <a:r>
+              <a:t>LECTURER CUE</a:t>
+            </a:r>
+          </a:p>
+          <a:p>
+            <a:r>
+              <a:t>A question with three things attached: a NUMBER you will produce, a POPULATION it covers, and a TIME WINDOW. Without all three, two people can agree on the answer and still disagree about what it meant.</a:t>
+            </a:r>
+          </a:p>
+          <a:p>
+            <a:r>
+              <a:t/>
+            </a:r>
+          </a:p>
+          <a:p>
+            <a:r>
+              <a:t>EXPLAIN IN ORDINARY WORDS</a:t>
+            </a:r>
+          </a:p>
+          <a:p>
+            <a:r>
+              <a:t>An observation describes the data. A finding answers a defined question with evidence. A recommendation adds an action, its justification and limits.</a:t>
+            </a:r>
+          </a:p>
+          <a:p>
+            <a:r>
+              <a:t/>
+            </a:r>
+          </a:p>
+          <a:p>
+            <a:r>
+              <a:t>CHECK AND EXPECTED ANSWER</a:t>
+            </a:r>
+          </a:p>
+          <a:p>
+            <a:r>
+              <a:t>Does a difference between two groups prove one caused the other? No. Other differences or selection may explain it.</a:t>
+            </a:r>
+          </a:p>
+          <a:p>
+            <a:r>
+              <a:t/>
+            </a:r>
+          </a:p>
+          <a:p>
+            <a:r>
+              <a:t>IF LEARNERS ARE STUCK</a:t>
+            </a:r>
+          </a:p>
+          <a:p>
+            <a:r>
+              <a:t>Ask for the population, time period, number and comparison. Then ask what additional evidence could change the recommendation.</a:t>
+            </a:r>
+          </a:p>
+          <a:p>
+            <a:r>
+              <a:t/>
+            </a:r>
+          </a:p>
+          <a:p>
+            <a:r>
+              <a:t>NEXT</a:t>
+            </a:r>
+          </a:p>
+          <a:p>
+            <a:r>
+              <a:t>Grain. Move on after a learner can explain the current example or required action.</a:t>
+            </a:r>
+          </a:p>
+        </p:txBody>
+      </p:sp>
+      <p:sp>
+        <p:nvSpPr>
+          <p:cNvPr id="4" name="Slide Number Placeholder 3"/>
+          <p:cNvSpPr>
+            <a:spLocks noGrp="1"/>
+          </p:cNvSpPr>
+          <p:nvPr>
+            <p:ph type="sldNum" idx="5" sz="quarter"/>
+          </p:nvPr>
+        </p:nvSpPr>
+        <p:spPr/>
+      </p:sp>
+    </p:spTree>
+  </p:cSld>
+  <p:clrMapOvr>
+    <a:masterClrMapping/>
+  </p:clrMapOvr>
+</p:notes>
+</file>
+
+<file path=ppt/notesSlides/notesSlide9.xml><?xml version="1.0" encoding="utf-8"?>
+<p:notes xmlns:a="http://schemas.openxmlformats.org/drawingml/2006/main" xmlns:p="http://schemas.openxmlformats.org/presentationml/2006/main">
+  <p:cSld>
+    <p:spTree>
+      <p:nvGrpSpPr>
+        <p:cNvPr id="1" name=""/>
+        <p:cNvGrpSpPr/>
+        <p:nvPr/>
+      </p:nvGrpSpPr>
+      <p:grpSpPr>
+        <a:xfrm>
+          <a:off x="0" y="0"/>
+          <a:ext cx="0" cy="0"/>
+          <a:chOff x="0" y="0"/>
+          <a:chExt cx="0" cy="0"/>
+        </a:xfrm>
+      </p:grpSpPr>
+      <p:sp>
+        <p:nvSpPr>
+          <p:cNvPr id="2" name="Slide Image Placeholder 1"/>
+          <p:cNvSpPr>
+            <a:spLocks noGrp="1"/>
+          </p:cNvSpPr>
+          <p:nvPr>
+            <p:ph type="sldImg" idx="2"/>
+          </p:nvPr>
+        </p:nvSpPr>
+        <p:spPr/>
+      </p:sp>
+      <p:sp>
+        <p:nvSpPr>
+          <p:cNvPr id="3" name="Notes Placeholder 2"/>
+          <p:cNvSpPr>
+            <a:spLocks noGrp="1"/>
+          </p:cNvSpPr>
+          <p:nvPr>
+            <p:ph type="body" idx="3" sz="quarter"/>
+          </p:nvPr>
+        </p:nvSpPr>
+        <p:spPr/>
+        <p:txBody>
+          <a:bodyPr/>
+          <a:lstStyle/>
+          <a:p>
+            <a:r>
+              <a:t>TEACHING PURPOSE</a:t>
+            </a:r>
+          </a:p>
+          <a:p>
+            <a:r>
+              <a:t>Grain</a:t>
+            </a:r>
+          </a:p>
+          <a:p>
+            <a:r>
+              <a:t/>
+            </a:r>
+          </a:p>
+          <a:p>
+            <a:r>
+              <a:t>CONNECT</a:t>
+            </a:r>
+          </a:p>
+          <a:p>
+            <a:r>
+              <a:t>Build on the preceding slide: An answerable question.</a:t>
+            </a:r>
+          </a:p>
+          <a:p>
+            <a:r>
+              <a:t/>
+            </a:r>
+          </a:p>
+          <a:p>
+            <a:r>
+              <a:t>LECTURER CUE</a:t>
+            </a:r>
+          </a:p>
+          <a:p>
+            <a:r>
               <a:t>What one row of a table represents. It is the single most important fact about any table and the one nobody states out loud.</a:t>
+            </a:r>
+          </a:p>
+          <a:p>
+            <a:r>
+              <a:t/>
+            </a:r>
+          </a:p>
+          <a:p>
+            <a:r>
+              <a:t>EXPLAIN IN ORDINARY WORDS</a:t>
+            </a:r>
+          </a:p>
+          <a:p>
+            <a:r>
+              <a:t>Grain means what one row represents. A key identifies a row; a primary key may use more than one column. A join matches keys, and multiple matches can multiply rows.</a:t>
+            </a:r>
+          </a:p>
+          <a:p>
+            <a:r>
+              <a:t/>
+            </a:r>
+          </a:p>
+          <a:p>
+            <a:r>
+              <a:t>CHECK AND EXPECTED ANSWER</a:t>
+            </a:r>
+          </a:p>
+          <a:p>
+            <a:r>
+              <a:t>One order has two lines. After joining orders to lines, how many rows for it? Two. Summing a repeated order-level total would double-count.</a:t>
+            </a:r>
+          </a:p>
+          <a:p>
+            <a:r>
+              <a:t/>
+            </a:r>
+          </a:p>
+          <a:p>
+            <a:r>
+              <a:t>IF LEARNERS ARE STUCK</a:t>
+            </a:r>
+          </a:p>
+          <a:p>
+            <a:r>
+              <a:t>Write one example row from each table. Circle keys and trace each match. Aggregate to the intended grain and check counts and totals.</a:t>
+            </a:r>
+          </a:p>
+          <a:p>
+            <a:r>
+              <a:t/>
+            </a:r>
+          </a:p>
+          <a:p>
+            <a:r>
+              <a:t>NEXT</a:t>
+            </a:r>
+          </a:p>
+          <a:p>
+            <a:r>
+              <a:t>Data type. Move on after a learner can explain the current example or required action.</a:t>
             </a:r>
           </a:p>
         </p:txBody>
@@ -5540,7 +7693,7 @@
 </file>
 
 <file path=ppt/slides/slide11.xml><?xml version="1.0" encoding="utf-8"?>
-<p:sld xmlns:a="http://schemas.openxmlformats.org/drawingml/2006/main" xmlns:p="http://schemas.openxmlformats.org/presentationml/2006/main" xmlns:r="http://schemas.openxmlformats.org/officeDocument/2006/relationships">
+<p:sld xmlns:a="http://schemas.openxmlformats.org/drawingml/2006/main" xmlns:p="http://schemas.openxmlformats.org/presentationml/2006/main">
   <p:cSld>
     <p:spTree>
       <p:nvGrpSpPr>
@@ -5709,7 +7862,7 @@
                 </a:solidFill>
                 <a:latin typeface="Calibri"/>
               </a:rPr>
-              <a:t>What kind of value a column holds: whole number, decimal, text, date, or true/false. A column has ONE type, all the way down.</a:t>
+              <a:t>A column’s intended type: integer, decimal, text, date or Boolean. Check imported values.</a:t>
             </a:r>
           </a:p>
         </p:txBody>
@@ -6263,7 +8416,7 @@
                 </a:solidFill>
                 <a:latin typeface="Calibri"/>
               </a:rPr>
-              <a:t>The words, on a real table. The anatomy figure on the screen and the same five rows open in Excel: row, column, cell, header, primary key, and the Excel word beside each. Then data types, and grain, which is the one that</a:t>
+              <a:t>The words, on a real table.</a:t>
             </a:r>
           </a:p>
         </p:txBody>
@@ -7578,7 +9731,7 @@
         <p:spPr>
           <a:xfrm>
             <a:off x="685800" y="1600200"/>
-            <a:ext cx="10820095" cy="1100371"/>
+            <a:ext cx="10820095" cy="1603291"/>
           </a:xfrm>
           <a:prstGeom prst="rect">
             <a:avLst/>
@@ -7619,7 +9772,7 @@
         </p:nvSpPr>
         <p:spPr>
           <a:xfrm>
-            <a:off x="685800" y="2792011"/>
+            <a:off x="685800" y="3477811"/>
             <a:ext cx="10820095" cy="457200"/>
           </a:xfrm>
           <a:prstGeom prst="rect">
@@ -10725,7 +12878,7 @@
         <p:spPr>
           <a:xfrm>
             <a:off x="685800" y="1911095"/>
-            <a:ext cx="10820095" cy="1243584"/>
+            <a:ext cx="10820095" cy="1617199"/>
           </a:xfrm>
           <a:prstGeom prst="roundRect">
             <a:avLst>
@@ -10770,7 +12923,7 @@
         <p:spPr>
           <a:xfrm>
             <a:off x="978408" y="2112264"/>
-            <a:ext cx="10234879" cy="877823"/>
+            <a:ext cx="10234879" cy="1251439"/>
           </a:xfrm>
           <a:prstGeom prst="rect">
             <a:avLst/>
@@ -10811,7 +12964,7 @@
         </p:nvSpPr>
         <p:spPr>
           <a:xfrm>
-            <a:off x="685800" y="3465575"/>
+            <a:off x="685800" y="3802615"/>
             <a:ext cx="10820095" cy="310896"/>
           </a:xfrm>
           <a:prstGeom prst="rect">
@@ -10837,7 +12990,7 @@
                 </a:solidFill>
                 <a:latin typeface="Calibri"/>
               </a:rPr>
-              <a:t>Work these questions in order:</a:t>
+              <a:t>Work these questions in order</a:t>
             </a:r>
           </a:p>
         </p:txBody>
@@ -10850,8 +13003,8 @@
         </p:nvSpPr>
         <p:spPr>
           <a:xfrm>
-            <a:off x="685800" y="3886200"/>
-            <a:ext cx="5227167" cy="365760"/>
+            <a:off x="685800" y="4278103"/>
+            <a:ext cx="5227167" cy="385501"/>
           </a:xfrm>
           <a:prstGeom prst="rect">
             <a:avLst/>
@@ -10879,7 +13032,7 @@
                 </a:solidFill>
                 <a:latin typeface="Calibri"/>
               </a:rPr>
-              <a:t>→  One row of this file is ___ .</a:t>
+              <a:t>One row of this file is ___ .</a:t>
             </a:r>
           </a:p>
         </p:txBody>
@@ -10892,8 +13045,8 @@
         </p:nvSpPr>
         <p:spPr>
           <a:xfrm>
-            <a:off x="685800" y="4306824"/>
-            <a:ext cx="5227167" cy="365760"/>
+            <a:off x="685800" y="4755045"/>
+            <a:ext cx="5227167" cy="385501"/>
           </a:xfrm>
           <a:prstGeom prst="rect">
             <a:avLst/>
@@ -10921,7 +13074,7 @@
                 </a:solidFill>
                 <a:latin typeface="Calibri"/>
               </a:rPr>
-              <a:t>→  How many rows? Write the number down.</a:t>
+              <a:t>How many rows? Write the number down.</a:t>
             </a:r>
           </a:p>
         </p:txBody>
@@ -10934,8 +13087,8 @@
         </p:nvSpPr>
         <p:spPr>
           <a:xfrm>
-            <a:off x="685800" y="4727448"/>
-            <a:ext cx="5227167" cy="365760"/>
+            <a:off x="685800" y="5231987"/>
+            <a:ext cx="5227167" cy="385501"/>
           </a:xfrm>
           <a:prstGeom prst="rect">
             <a:avLst/>
@@ -10963,7 +13116,7 @@
                 </a:solidFill>
                 <a:latin typeface="Calibri"/>
               </a:rPr>
-              <a:t>→  Which column never repeats? That is the primary key.</a:t>
+              <a:t>Which column never repeats? That is the primary key.</a:t>
             </a:r>
           </a:p>
         </p:txBody>
@@ -10976,8 +13129,8 @@
         </p:nvSpPr>
         <p:spPr>
           <a:xfrm>
-            <a:off x="6278727" y="3886200"/>
-            <a:ext cx="5227167" cy="365760"/>
+            <a:off x="6278727" y="4278103"/>
+            <a:ext cx="5227167" cy="385501"/>
           </a:xfrm>
           <a:prstGeom prst="rect">
             <a:avLst/>
@@ -11005,7 +13158,7 @@
                 </a:solidFill>
                 <a:latin typeface="Calibri"/>
               </a:rPr>
-              <a:t>→  Which column points at another table?</a:t>
+              <a:t>Which column points at another table?</a:t>
             </a:r>
           </a:p>
         </p:txBody>
@@ -11018,8 +13171,8 @@
         </p:nvSpPr>
         <p:spPr>
           <a:xfrm>
-            <a:off x="6278727" y="4306824"/>
-            <a:ext cx="5227167" cy="365760"/>
+            <a:off x="6278727" y="4755045"/>
+            <a:ext cx="5227167" cy="697851"/>
           </a:xfrm>
           <a:prstGeom prst="rect">
             <a:avLst/>
@@ -11047,7 +13200,7 @@
                 </a:solidFill>
                 <a:latin typeface="Calibri"/>
               </a:rPr>
-              <a:t>→  Then: the three requests, rewritten with a number, a population and a window.</a:t>
+              <a:t>Then: the three requests, rewritten with a number, a population and a window.</a:t>
             </a:r>
           </a:p>
         </p:txBody>
@@ -11923,7 +14076,7 @@
 </file>
 
 <file path=ppt/slides/slide3.xml><?xml version="1.0" encoding="utf-8"?>
-<p:sld xmlns:a="http://schemas.openxmlformats.org/drawingml/2006/main" xmlns:p="http://schemas.openxmlformats.org/presentationml/2006/main" xmlns:r="http://schemas.openxmlformats.org/officeDocument/2006/relationships">
+<p:sld xmlns:a="http://schemas.openxmlformats.org/drawingml/2006/main" xmlns:p="http://schemas.openxmlformats.org/presentationml/2006/main">
   <p:cSld>
     <p:spTree>
       <p:nvGrpSpPr>
@@ -13141,7 +15294,7 @@
                 </a:solidFill>
                 <a:latin typeface="Calibri"/>
               </a:rPr>
-              <a:t>What kind of value a column holds: whole number, decimal, text, date, or true/false. A column has ONE type, all the way down.</a:t>
+              <a:t>A column’s intended type: integer, decimal, text, date or Boolean. Check imported values.</a:t>
             </a:r>
           </a:p>
         </p:txBody>
@@ -14118,7 +16271,7 @@
                 </a:solidFill>
                 <a:latin typeface="Calibri"/>
               </a:rPr>
-              <a:t>Requests against questions. Four real requests from a manager, each rewritten into a question you could actually answer, and one rewritten three different ways to show the original was ambiguous. The rule for the rest of</a:t>
+              <a:t>Requests against questions.</a:t>
             </a:r>
           </a:p>
         </p:txBody>
@@ -14947,7 +17100,7 @@
 </file>
 
 <file path=ppt/slides/slide8.xml><?xml version="1.0" encoding="utf-8"?>
-<p:sld xmlns:a="http://schemas.openxmlformats.org/drawingml/2006/main" xmlns:p="http://schemas.openxmlformats.org/presentationml/2006/main" xmlns:r="http://schemas.openxmlformats.org/officeDocument/2006/relationships">
+<p:sld xmlns:a="http://schemas.openxmlformats.org/drawingml/2006/main" xmlns:p="http://schemas.openxmlformats.org/presentationml/2006/main">
   <p:cSld>
     <p:spTree>
       <p:nvGrpSpPr>
@@ -15390,7 +17543,7 @@
                 </a:solidFill>
                 <a:latin typeface="Calibri"/>
               </a:rPr>
-              <a:t>=IF(B2&gt;1000,"large","small") is a function, two arguments, a condition and a result. Session 6 puts the brackets somewhere else.</a:t>
+              <a:t>=IF(B2&gt;1000,"large","small") is a function with three arguments: a condition and two possible results. Session 6 puts the brackets somewhere else.</a:t>
             </a:r>
           </a:p>
         </p:txBody>

</xml_diff>